<commit_message>
Remove slide 3 (shoring basis); keep timeline + remaining-works Gantt
Co-Authored-By: Claude Sonnet 5.5 <noreply@anthropic.com>
Claude-Session: https://claude.ai/code/session_015CooLRRU7X55XCWBXAPEMd
</commit_message>
<xml_diff>
--- a/ufwl-timeline/UFWL_Presentation_AR.pptx
+++ b/ufwl-timeline/UFWL_Presentation_AR.pptx
@@ -7,10 +7,9 @@
   <p:sldIdLst>
     <p:sldId id="256" r:id="rId2"/>
     <p:sldId id="257" r:id="rId3"/>
-    <p:sldId id="258" r:id="rId4"/>
   </p:sldIdLst>
   <p:notesMasterIdLst>
-    <p:notesMasterId r:id="rId5"/>
+    <p:notesMasterId r:id="rId4"/>
   </p:notesMasterIdLst>
   <p:sldSz cx="12192000" cy="6858000"/>
   <p:notesSz cx="6858000" cy="12192000"/>
@@ -634,94 +633,6 @@
 </p:notes>
 </file>
 
-<file path=ppt/notesSlides/notesSlide3.xml><?xml version="1.0" encoding="utf-8"?>
-<p:notes xmlns:a="http://schemas.openxmlformats.org/drawingml/2006/main" xmlns:r="http://schemas.openxmlformats.org/officeDocument/2006/relationships" xmlns:p="http://schemas.openxmlformats.org/presentationml/2006/main">
-  <p:cSld>
-    <p:spTree>
-      <p:nvGrpSpPr>
-        <p:cNvPr id="1" name=""/>
-        <p:cNvGrpSpPr/>
-        <p:nvPr/>
-      </p:nvGrpSpPr>
-      <p:grpSpPr>
-        <a:xfrm>
-          <a:off x="0" y="0"/>
-          <a:ext cx="0" cy="0"/>
-          <a:chOff x="0" y="0"/>
-          <a:chExt cx="0" cy="0"/>
-        </a:xfrm>
-      </p:grpSpPr>
-      <p:sp>
-        <p:nvSpPr>
-          <p:cNvPr id="2" name="Slide Image Placeholder 1"/>
-          <p:cNvSpPr>
-            <a:spLocks noGrp="1" noRot="1" noChangeAspect="1"/>
-          </p:cNvSpPr>
-          <p:nvPr>
-            <p:ph type="sldImg"/>
-          </p:nvPr>
-        </p:nvSpPr>
-        <p:spPr/>
-      </p:sp>
-      <p:sp>
-        <p:nvSpPr>
-          <p:cNvPr id="3" name="Notes Placeholder 2"/>
-          <p:cNvSpPr>
-            <a:spLocks noGrp="1"/>
-          </p:cNvSpPr>
-          <p:nvPr>
-            <p:ph type="body" idx="1"/>
-          </p:nvPr>
-        </p:nvSpPr>
-        <p:spPr/>
-        <p:txBody>
-          <a:bodyPr/>
-          <a:lstStyle/>
-          <a:p>
-            <a:r>
-              <a:rPr lang="en-US" dirty="0"/>
-              <a:t/>
-            </a:r>
-            <a:endParaRPr lang="en-US" dirty="0"/>
-          </a:p>
-        </p:txBody>
-      </p:sp>
-      <p:sp>
-        <p:nvSpPr>
-          <p:cNvPr id="4" name="Slide Number Placeholder 3"/>
-          <p:cNvSpPr>
-            <a:spLocks noGrp="1"/>
-          </p:cNvSpPr>
-          <p:nvPr>
-            <p:ph type="sldNum" sz="quarter" idx="10"/>
-          </p:nvPr>
-        </p:nvSpPr>
-        <p:spPr/>
-        <p:txBody>
-          <a:bodyPr/>
-          <a:lstStyle/>
-          <a:p>
-            <a:fld id="{F7021451-1387-4CA6-816F-3879F97B5CBC}" type="slidenum">
-              <a:rPr lang="en-US"/>
-              <a:t>3</a:t>
-            </a:fld>
-            <a:endParaRPr lang="en-US"/>
-          </a:p>
-        </p:txBody>
-      </p:sp>
-    </p:spTree>
-    <p:extLst>
-      <p:ext uri="{BB962C8B-B14F-4D97-AF65-F5344CB8AC3E}">
-        <p14:creationId xmlns:p14="http://schemas.microsoft.com/office/powerpoint/2010/main" val="1024086991"/>
-      </p:ext>
-    </p:extLst>
-  </p:cSld>
-  <p:clrMapOvr>
-    <a:masterClrMapping/>
-  </p:clrMapOvr>
-</p:notes>
-</file>
-
 <file path=ppt/slideLayouts/slideLayout1.xml><?xml version="1.0" encoding="utf-8"?>
 <p:sldLayout xmlns:a="http://schemas.openxmlformats.org/drawingml/2006/main" xmlns:r="http://schemas.openxmlformats.org/officeDocument/2006/relationships" xmlns:p="http://schemas.openxmlformats.org/presentationml/2006/main" preserve="1">
   <p:cSld name="DEFAULT">
@@ -20450,2103 +20361,6 @@
             <a:fld id="{F7021451-1387-4CA6-816F-3879F97B5CBC}" type="slidenum">
               <a:rPr b="0" lang="en-US"/>
               <a:t>2</a:t>
-            </a:fld>
-            <a:endParaRPr lang="en-US"/>
-          </a:p>
-        </p:txBody>
-      </p:sp>
-    </p:spTree>
-  </p:cSld>
-  <p:clrMapOvr>
-    <a:masterClrMapping/>
-  </p:clrMapOvr>
-</p:sld>
-</file>
-
-<file path=ppt/slides/slide3.xml><?xml version="1.0" encoding="utf-8"?>
-<p:sld xmlns:a="http://schemas.openxmlformats.org/drawingml/2006/main" xmlns:r="http://schemas.openxmlformats.org/officeDocument/2006/relationships" xmlns:p="http://schemas.openxmlformats.org/presentationml/2006/main">
-  <p:cSld name="Slide 3">
-    <p:spTree>
-      <p:nvGrpSpPr>
-        <p:cNvPr id="1" name=""/>
-        <p:cNvGrpSpPr/>
-        <p:nvPr/>
-      </p:nvGrpSpPr>
-      <p:grpSpPr>
-        <a:xfrm>
-          <a:off x="0" y="0"/>
-          <a:ext cx="0" cy="0"/>
-          <a:chOff x="0" y="0"/>
-          <a:chExt cx="0" cy="0"/>
-        </a:xfrm>
-      </p:grpSpPr>
-      <p:sp>
-        <p:nvSpPr>
-          <p:cNvPr id="2" name="Text 0"/>
-          <p:cNvSpPr/>
-          <p:nvPr/>
-        </p:nvSpPr>
-        <p:spPr>
-          <a:xfrm>
-            <a:off x="1691640" y="109728"/>
-            <a:ext cx="10134295" cy="457200"/>
-          </a:xfrm>
-          <a:prstGeom prst="rect">
-            <a:avLst/>
-          </a:prstGeom>
-          <a:noFill/>
-          <a:ln/>
-        </p:spPr>
-        <p:txBody>
-          <a:bodyPr wrap="square" lIns="0" tIns="0" rIns="0" bIns="0" rtlCol="0" anchor="ctr">
-            <a:normAutofit/>
-          </a:bodyPr>
-          <a:lstStyle/>
-          <a:p>
-            <a:pPr rtl="1" algn="r" indent="0" marL="0">
-              <a:buNone/>
-            </a:pPr>
-            <a:r>
-              <a:rPr lang="ar-SA" altLang="en-US" sz="2400" b="1" dirty="0">
-                <a:solidFill>
-                  <a:srgbClr val="3D3935"/>
-                </a:solidFill>
-                <a:latin typeface="Arial" pitchFamily="34" charset="0"/>
-                <a:ea typeface="Arial" pitchFamily="34" charset="-122"/>
-                <a:cs typeface="Arial" pitchFamily="34" charset="-120"/>
-              </a:rPr>
-              <a:t>أنشطة الدعم (Shoring) وأسس الجدول</a:t>
-            </a:r>
-            <a:endParaRPr lang="ar-SA" sz="2400" dirty="0"/>
-          </a:p>
-        </p:txBody>
-      </p:sp>
-      <p:sp>
-        <p:nvSpPr>
-          <p:cNvPr id="3" name="Text 1"/>
-          <p:cNvSpPr/>
-          <p:nvPr/>
-        </p:nvSpPr>
-        <p:spPr>
-          <a:xfrm>
-            <a:off x="1691640" y="548640"/>
-            <a:ext cx="10134295" cy="256032"/>
-          </a:xfrm>
-          <a:prstGeom prst="rect">
-            <a:avLst/>
-          </a:prstGeom>
-          <a:noFill/>
-          <a:ln/>
-        </p:spPr>
-        <p:txBody>
-          <a:bodyPr wrap="square" lIns="0" tIns="0" rIns="0" bIns="0" rtlCol="0" anchor="ctr">
-            <a:normAutofit/>
-          </a:bodyPr>
-          <a:lstStyle/>
-          <a:p>
-            <a:pPr rtl="1" algn="r" indent="0" marL="0">
-              <a:buNone/>
-            </a:pPr>
-            <a:r>
-              <a:rPr lang="ar-SA" altLang="en-US" sz="1200" dirty="0">
-                <a:solidFill>
-                  <a:srgbClr val="66707A"/>
-                </a:solidFill>
-                <a:latin typeface="Arial" pitchFamily="34" charset="0"/>
-                <a:ea typeface="Arial" pitchFamily="34" charset="-122"/>
-                <a:cs typeface="Arial" pitchFamily="34" charset="-120"/>
-              </a:rPr>
-              <a:t>تسلسل أعمال الدعم والتواريخ الرئيسية وشروط البرنامج المقترح</a:t>
-            </a:r>
-            <a:endParaRPr lang="ar-SA" sz="1200" dirty="0"/>
-          </a:p>
-        </p:txBody>
-      </p:sp>
-      <p:sp>
-        <p:nvSpPr>
-          <p:cNvPr id="4" name="Shape 2"/>
-          <p:cNvSpPr/>
-          <p:nvPr/>
-        </p:nvSpPr>
-        <p:spPr>
-          <a:xfrm>
-            <a:off x="11771071" y="1133856"/>
-            <a:ext cx="54864" cy="256032"/>
-          </a:xfrm>
-          <a:prstGeom prst="rect">
-            <a:avLst/>
-          </a:prstGeom>
-          <a:solidFill>
-            <a:srgbClr val="00778B"/>
-          </a:solidFill>
-          <a:ln w="12700">
-            <a:solidFill>
-              <a:srgbClr val="00778B"/>
-            </a:solidFill>
-            <a:prstDash val="solid"/>
-          </a:ln>
-        </p:spPr>
-      </p:sp>
-      <p:sp>
-        <p:nvSpPr>
-          <p:cNvPr id="5" name="Text 3"/>
-          <p:cNvSpPr/>
-          <p:nvPr/>
-        </p:nvSpPr>
-        <p:spPr>
-          <a:xfrm>
-            <a:off x="4364431" y="1097280"/>
-            <a:ext cx="7315200" cy="329184"/>
-          </a:xfrm>
-          <a:prstGeom prst="rect">
-            <a:avLst/>
-          </a:prstGeom>
-          <a:noFill/>
-          <a:ln/>
-        </p:spPr>
-        <p:txBody>
-          <a:bodyPr wrap="square" lIns="0" tIns="0" rIns="0" bIns="0" rtlCol="0" anchor="ctr">
-            <a:normAutofit/>
-          </a:bodyPr>
-          <a:lstStyle/>
-          <a:p>
-            <a:pPr rtl="1" algn="r" indent="0" marL="0">
-              <a:buNone/>
-            </a:pPr>
-            <a:r>
-              <a:rPr lang="ar-SA" altLang="en-US" sz="1500" b="1" dirty="0">
-                <a:solidFill>
-                  <a:srgbClr val="3D3935"/>
-                </a:solidFill>
-                <a:latin typeface="Arial" pitchFamily="34" charset="0"/>
-                <a:ea typeface="Arial" pitchFamily="34" charset="-122"/>
-                <a:cs typeface="Arial" pitchFamily="34" charset="-120"/>
-              </a:rPr>
-              <a:t>تسلسل أعمال الدعم (النشاط A)</a:t>
-            </a:r>
-            <a:endParaRPr lang="ar-SA" sz="1500" dirty="0"/>
-          </a:p>
-        </p:txBody>
-      </p:sp>
-      <p:sp>
-        <p:nvSpPr>
-          <p:cNvPr id="6" name="Text 4"/>
-          <p:cNvSpPr/>
-          <p:nvPr/>
-        </p:nvSpPr>
-        <p:spPr>
-          <a:xfrm>
-            <a:off x="3450031" y="1417320"/>
-            <a:ext cx="8229600" cy="256032"/>
-          </a:xfrm>
-          <a:prstGeom prst="rect">
-            <a:avLst/>
-          </a:prstGeom>
-          <a:noFill/>
-          <a:ln/>
-        </p:spPr>
-        <p:txBody>
-          <a:bodyPr wrap="square" lIns="0" tIns="0" rIns="0" bIns="0" rtlCol="0" anchor="ctr">
-            <a:normAutofit/>
-          </a:bodyPr>
-          <a:lstStyle/>
-          <a:p>
-            <a:pPr rtl="1" algn="r" indent="0" marL="0">
-              <a:buNone/>
-            </a:pPr>
-            <a:r>
-              <a:rPr lang="ar-SA" altLang="en-US" sz="1100" b="1" dirty="0">
-                <a:solidFill>
-                  <a:srgbClr val="C8503F"/>
-                </a:solidFill>
-                <a:latin typeface="Arial" pitchFamily="34" charset="0"/>
-                <a:ea typeface="Arial" pitchFamily="34" charset="-122"/>
-                <a:cs typeface="Arial" pitchFamily="34" charset="-120"/>
-              </a:rPr>
-              <a:t>13 أكتوبر 2026 → 19 أكتوبر 2026 · 6 يوم عمل</a:t>
-            </a:r>
-            <a:endParaRPr lang="ar-SA" sz="1100" dirty="0"/>
-          </a:p>
-        </p:txBody>
-      </p:sp>
-      <p:sp>
-        <p:nvSpPr>
-          <p:cNvPr id="7" name="Shape 5"/>
-          <p:cNvSpPr/>
-          <p:nvPr/>
-        </p:nvSpPr>
-        <p:spPr>
-          <a:xfrm flipH="1">
-            <a:off x="9460748" y="1783080"/>
-            <a:ext cx="2365187" cy="1051560"/>
-          </a:xfrm>
-          <a:prstGeom prst="chevron">
-            <a:avLst/>
-          </a:prstGeom>
-          <a:solidFill>
-            <a:srgbClr val="F4DAD6"/>
-          </a:solidFill>
-          <a:ln w="12700">
-            <a:solidFill>
-              <a:srgbClr val="F4DAD6"/>
-            </a:solidFill>
-            <a:prstDash val="solid"/>
-          </a:ln>
-        </p:spPr>
-      </p:sp>
-      <p:sp>
-        <p:nvSpPr>
-          <p:cNvPr id="8" name="Shape 6"/>
-          <p:cNvSpPr/>
-          <p:nvPr/>
-        </p:nvSpPr>
-        <p:spPr>
-          <a:xfrm>
-            <a:off x="11185855" y="1874520"/>
-            <a:ext cx="274320" cy="274320"/>
-          </a:xfrm>
-          <a:prstGeom prst="ellipse">
-            <a:avLst/>
-          </a:prstGeom>
-          <a:solidFill>
-            <a:srgbClr val="C8503F"/>
-          </a:solidFill>
-          <a:ln w="12700">
-            <a:solidFill>
-              <a:srgbClr val="C8503F"/>
-            </a:solidFill>
-            <a:prstDash val="solid"/>
-          </a:ln>
-        </p:spPr>
-      </p:sp>
-      <p:sp>
-        <p:nvSpPr>
-          <p:cNvPr id="9" name="Text 7"/>
-          <p:cNvSpPr/>
-          <p:nvPr/>
-        </p:nvSpPr>
-        <p:spPr>
-          <a:xfrm>
-            <a:off x="11185855" y="1874520"/>
-            <a:ext cx="274320" cy="274320"/>
-          </a:xfrm>
-          <a:prstGeom prst="rect">
-            <a:avLst/>
-          </a:prstGeom>
-          <a:noFill/>
-          <a:ln/>
-        </p:spPr>
-        <p:txBody>
-          <a:bodyPr wrap="square" lIns="0" tIns="0" rIns="0" bIns="0" rtlCol="0" anchor="ctr">
-            <a:normAutofit/>
-          </a:bodyPr>
-          <a:lstStyle/>
-          <a:p>
-            <a:pPr rtl="1" algn="ctr" indent="0" marL="0">
-              <a:buNone/>
-            </a:pPr>
-            <a:r>
-              <a:rPr lang="ar-SA" altLang="en-US" sz="1000" b="1" dirty="0">
-                <a:solidFill>
-                  <a:srgbClr val="FFFFFF"/>
-                </a:solidFill>
-                <a:latin typeface="Arial" pitchFamily="34" charset="0"/>
-                <a:ea typeface="Arial" pitchFamily="34" charset="-122"/>
-                <a:cs typeface="Arial" pitchFamily="34" charset="-120"/>
-              </a:rPr>
-              <a:t>1</a:t>
-            </a:r>
-            <a:endParaRPr lang="ar-SA" sz="1000" dirty="0"/>
-          </a:p>
-        </p:txBody>
-      </p:sp>
-      <p:sp>
-        <p:nvSpPr>
-          <p:cNvPr id="10" name="Text 8"/>
-          <p:cNvSpPr/>
-          <p:nvPr/>
-        </p:nvSpPr>
-        <p:spPr>
-          <a:xfrm>
-            <a:off x="9835652" y="2157984"/>
-            <a:ext cx="1606235" cy="411480"/>
-          </a:xfrm>
-          <a:prstGeom prst="rect">
-            <a:avLst/>
-          </a:prstGeom>
-          <a:noFill/>
-          <a:ln/>
-        </p:spPr>
-        <p:txBody>
-          <a:bodyPr wrap="square" lIns="0" tIns="0" rIns="0" bIns="0" rtlCol="0" anchor="t">
-            <a:normAutofit/>
-          </a:bodyPr>
-          <a:lstStyle/>
-          <a:p>
-            <a:pPr rtl="1" algn="r" indent="0" marL="0">
-              <a:buNone/>
-            </a:pPr>
-            <a:r>
-              <a:rPr lang="ar-SA" altLang="en-US" sz="1100" b="1" dirty="0">
-                <a:solidFill>
-                  <a:srgbClr val="3D3935"/>
-                </a:solidFill>
-                <a:latin typeface="Arial" pitchFamily="34" charset="0"/>
-                <a:ea typeface="Arial" pitchFamily="34" charset="-122"/>
-                <a:cs typeface="Arial" pitchFamily="34" charset="-120"/>
-              </a:rPr>
-              <a:t>الحفر لأعمدة H-Beam</a:t>
-            </a:r>
-            <a:endParaRPr lang="ar-SA" sz="1100" dirty="0"/>
-          </a:p>
-        </p:txBody>
-      </p:sp>
-      <p:sp>
-        <p:nvSpPr>
-          <p:cNvPr id="11" name="Text 9"/>
-          <p:cNvSpPr/>
-          <p:nvPr/>
-        </p:nvSpPr>
-        <p:spPr>
-          <a:xfrm>
-            <a:off x="9835652" y="2542032"/>
-            <a:ext cx="1606235" cy="228600"/>
-          </a:xfrm>
-          <a:prstGeom prst="rect">
-            <a:avLst/>
-          </a:prstGeom>
-          <a:noFill/>
-          <a:ln/>
-        </p:spPr>
-        <p:txBody>
-          <a:bodyPr wrap="square" lIns="0" tIns="0" rIns="0" bIns="0" rtlCol="0" anchor="t">
-            <a:normAutofit/>
-          </a:bodyPr>
-          <a:lstStyle/>
-          <a:p>
-            <a:pPr rtl="1" algn="r" indent="0" marL="0">
-              <a:buNone/>
-            </a:pPr>
-            <a:r>
-              <a:rPr lang="ar-SA" altLang="en-US" sz="750" b="1" dirty="0">
-                <a:solidFill>
-                  <a:srgbClr val="7A3A30"/>
-                </a:solidFill>
-                <a:latin typeface="Arial" pitchFamily="34" charset="0"/>
-                <a:ea typeface="Arial" pitchFamily="34" charset="-122"/>
-                <a:cs typeface="Arial" pitchFamily="34" charset="-120"/>
-              </a:rPr>
-              <a:t>13 أكتوبر → 14 أكتوبر · 2 يوم</a:t>
-            </a:r>
-            <a:endParaRPr lang="ar-SA" sz="750" dirty="0"/>
-          </a:p>
-        </p:txBody>
-      </p:sp>
-      <p:sp>
-        <p:nvSpPr>
-          <p:cNvPr id="12" name="Shape 10"/>
-          <p:cNvSpPr/>
-          <p:nvPr/>
-        </p:nvSpPr>
-        <p:spPr>
-          <a:xfrm flipH="1">
-            <a:off x="7168713" y="1783080"/>
-            <a:ext cx="2365187" cy="1051560"/>
-          </a:xfrm>
-          <a:prstGeom prst="chevron">
-            <a:avLst/>
-          </a:prstGeom>
-          <a:solidFill>
-            <a:srgbClr val="F4DAD6"/>
-          </a:solidFill>
-          <a:ln w="12700">
-            <a:solidFill>
-              <a:srgbClr val="F4DAD6"/>
-            </a:solidFill>
-            <a:prstDash val="solid"/>
-          </a:ln>
-        </p:spPr>
-      </p:sp>
-      <p:sp>
-        <p:nvSpPr>
-          <p:cNvPr id="13" name="Shape 11"/>
-          <p:cNvSpPr/>
-          <p:nvPr/>
-        </p:nvSpPr>
-        <p:spPr>
-          <a:xfrm>
-            <a:off x="8893820" y="1874520"/>
-            <a:ext cx="274320" cy="274320"/>
-          </a:xfrm>
-          <a:prstGeom prst="ellipse">
-            <a:avLst/>
-          </a:prstGeom>
-          <a:solidFill>
-            <a:srgbClr val="C8503F"/>
-          </a:solidFill>
-          <a:ln w="12700">
-            <a:solidFill>
-              <a:srgbClr val="C8503F"/>
-            </a:solidFill>
-            <a:prstDash val="solid"/>
-          </a:ln>
-        </p:spPr>
-      </p:sp>
-      <p:sp>
-        <p:nvSpPr>
-          <p:cNvPr id="14" name="Text 12"/>
-          <p:cNvSpPr/>
-          <p:nvPr/>
-        </p:nvSpPr>
-        <p:spPr>
-          <a:xfrm>
-            <a:off x="8893820" y="1874520"/>
-            <a:ext cx="274320" cy="274320"/>
-          </a:xfrm>
-          <a:prstGeom prst="rect">
-            <a:avLst/>
-          </a:prstGeom>
-          <a:noFill/>
-          <a:ln/>
-        </p:spPr>
-        <p:txBody>
-          <a:bodyPr wrap="square" lIns="0" tIns="0" rIns="0" bIns="0" rtlCol="0" anchor="ctr">
-            <a:normAutofit/>
-          </a:bodyPr>
-          <a:lstStyle/>
-          <a:p>
-            <a:pPr rtl="1" algn="ctr" indent="0" marL="0">
-              <a:buNone/>
-            </a:pPr>
-            <a:r>
-              <a:rPr lang="ar-SA" altLang="en-US" sz="1000" b="1" dirty="0">
-                <a:solidFill>
-                  <a:srgbClr val="FFFFFF"/>
-                </a:solidFill>
-                <a:latin typeface="Arial" pitchFamily="34" charset="0"/>
-                <a:ea typeface="Arial" pitchFamily="34" charset="-122"/>
-                <a:cs typeface="Arial" pitchFamily="34" charset="-120"/>
-              </a:rPr>
-              <a:t>2</a:t>
-            </a:r>
-            <a:endParaRPr lang="ar-SA" sz="1000" dirty="0"/>
-          </a:p>
-        </p:txBody>
-      </p:sp>
-      <p:sp>
-        <p:nvSpPr>
-          <p:cNvPr id="15" name="Text 13"/>
-          <p:cNvSpPr/>
-          <p:nvPr/>
-        </p:nvSpPr>
-        <p:spPr>
-          <a:xfrm>
-            <a:off x="7543617" y="2157984"/>
-            <a:ext cx="1606235" cy="411480"/>
-          </a:xfrm>
-          <a:prstGeom prst="rect">
-            <a:avLst/>
-          </a:prstGeom>
-          <a:noFill/>
-          <a:ln/>
-        </p:spPr>
-        <p:txBody>
-          <a:bodyPr wrap="square" lIns="0" tIns="0" rIns="0" bIns="0" rtlCol="0" anchor="t">
-            <a:normAutofit/>
-          </a:bodyPr>
-          <a:lstStyle/>
-          <a:p>
-            <a:pPr rtl="1" algn="r" indent="0" marL="0">
-              <a:buNone/>
-            </a:pPr>
-            <a:r>
-              <a:rPr lang="ar-SA" altLang="en-US" sz="1100" b="1" dirty="0">
-                <a:solidFill>
-                  <a:srgbClr val="3D3935"/>
-                </a:solidFill>
-                <a:latin typeface="Arial" pitchFamily="34" charset="0"/>
-                <a:ea typeface="Arial" pitchFamily="34" charset="-122"/>
-                <a:cs typeface="Arial" pitchFamily="34" charset="-120"/>
-              </a:rPr>
-              <a:t>تركيب أعمدة H-Beam</a:t>
-            </a:r>
-            <a:endParaRPr lang="ar-SA" sz="1100" dirty="0"/>
-          </a:p>
-        </p:txBody>
-      </p:sp>
-      <p:sp>
-        <p:nvSpPr>
-          <p:cNvPr id="16" name="Text 14"/>
-          <p:cNvSpPr/>
-          <p:nvPr/>
-        </p:nvSpPr>
-        <p:spPr>
-          <a:xfrm>
-            <a:off x="7543617" y="2542032"/>
-            <a:ext cx="1606235" cy="228600"/>
-          </a:xfrm>
-          <a:prstGeom prst="rect">
-            <a:avLst/>
-          </a:prstGeom>
-          <a:noFill/>
-          <a:ln/>
-        </p:spPr>
-        <p:txBody>
-          <a:bodyPr wrap="square" lIns="0" tIns="0" rIns="0" bIns="0" rtlCol="0" anchor="t">
-            <a:normAutofit/>
-          </a:bodyPr>
-          <a:lstStyle/>
-          <a:p>
-            <a:pPr rtl="1" algn="r" indent="0" marL="0">
-              <a:buNone/>
-            </a:pPr>
-            <a:r>
-              <a:rPr lang="ar-SA" altLang="en-US" sz="750" b="1" dirty="0">
-                <a:solidFill>
-                  <a:srgbClr val="7A3A30"/>
-                </a:solidFill>
-                <a:latin typeface="Arial" pitchFamily="34" charset="0"/>
-                <a:ea typeface="Arial" pitchFamily="34" charset="-122"/>
-                <a:cs typeface="Arial" pitchFamily="34" charset="-120"/>
-              </a:rPr>
-              <a:t>14 أكتوبر → 17 أكتوبر · 3 يوم · A1 SS +1</a:t>
-            </a:r>
-            <a:endParaRPr lang="ar-SA" sz="750" dirty="0"/>
-          </a:p>
-        </p:txBody>
-      </p:sp>
-      <p:sp>
-        <p:nvSpPr>
-          <p:cNvPr id="17" name="Shape 15"/>
-          <p:cNvSpPr/>
-          <p:nvPr/>
-        </p:nvSpPr>
-        <p:spPr>
-          <a:xfrm flipH="1">
-            <a:off x="4876678" y="1783080"/>
-            <a:ext cx="2365187" cy="1051560"/>
-          </a:xfrm>
-          <a:prstGeom prst="chevron">
-            <a:avLst/>
-          </a:prstGeom>
-          <a:solidFill>
-            <a:srgbClr val="F4DAD6"/>
-          </a:solidFill>
-          <a:ln w="12700">
-            <a:solidFill>
-              <a:srgbClr val="F4DAD6"/>
-            </a:solidFill>
-            <a:prstDash val="solid"/>
-          </a:ln>
-        </p:spPr>
-      </p:sp>
-      <p:sp>
-        <p:nvSpPr>
-          <p:cNvPr id="18" name="Shape 16"/>
-          <p:cNvSpPr/>
-          <p:nvPr/>
-        </p:nvSpPr>
-        <p:spPr>
-          <a:xfrm>
-            <a:off x="6601785" y="1874520"/>
-            <a:ext cx="274320" cy="274320"/>
-          </a:xfrm>
-          <a:prstGeom prst="ellipse">
-            <a:avLst/>
-          </a:prstGeom>
-          <a:solidFill>
-            <a:srgbClr val="C8503F"/>
-          </a:solidFill>
-          <a:ln w="12700">
-            <a:solidFill>
-              <a:srgbClr val="C8503F"/>
-            </a:solidFill>
-            <a:prstDash val="solid"/>
-          </a:ln>
-        </p:spPr>
-      </p:sp>
-      <p:sp>
-        <p:nvSpPr>
-          <p:cNvPr id="19" name="Text 17"/>
-          <p:cNvSpPr/>
-          <p:nvPr/>
-        </p:nvSpPr>
-        <p:spPr>
-          <a:xfrm>
-            <a:off x="6601785" y="1874520"/>
-            <a:ext cx="274320" cy="274320"/>
-          </a:xfrm>
-          <a:prstGeom prst="rect">
-            <a:avLst/>
-          </a:prstGeom>
-          <a:noFill/>
-          <a:ln/>
-        </p:spPr>
-        <p:txBody>
-          <a:bodyPr wrap="square" lIns="0" tIns="0" rIns="0" bIns="0" rtlCol="0" anchor="ctr">
-            <a:normAutofit/>
-          </a:bodyPr>
-          <a:lstStyle/>
-          <a:p>
-            <a:pPr rtl="1" algn="ctr" indent="0" marL="0">
-              <a:buNone/>
-            </a:pPr>
-            <a:r>
-              <a:rPr lang="ar-SA" altLang="en-US" sz="1000" b="1" dirty="0">
-                <a:solidFill>
-                  <a:srgbClr val="FFFFFF"/>
-                </a:solidFill>
-                <a:latin typeface="Arial" pitchFamily="34" charset="0"/>
-                <a:ea typeface="Arial" pitchFamily="34" charset="-122"/>
-                <a:cs typeface="Arial" pitchFamily="34" charset="-120"/>
-              </a:rPr>
-              <a:t>3</a:t>
-            </a:r>
-            <a:endParaRPr lang="ar-SA" sz="1000" dirty="0"/>
-          </a:p>
-        </p:txBody>
-      </p:sp>
-      <p:sp>
-        <p:nvSpPr>
-          <p:cNvPr id="20" name="Text 18"/>
-          <p:cNvSpPr/>
-          <p:nvPr/>
-        </p:nvSpPr>
-        <p:spPr>
-          <a:xfrm>
-            <a:off x="5251582" y="2157984"/>
-            <a:ext cx="1606235" cy="411480"/>
-          </a:xfrm>
-          <a:prstGeom prst="rect">
-            <a:avLst/>
-          </a:prstGeom>
-          <a:noFill/>
-          <a:ln/>
-        </p:spPr>
-        <p:txBody>
-          <a:bodyPr wrap="square" lIns="0" tIns="0" rIns="0" bIns="0" rtlCol="0" anchor="t">
-            <a:normAutofit/>
-          </a:bodyPr>
-          <a:lstStyle/>
-          <a:p>
-            <a:pPr rtl="1" algn="r" indent="0" marL="0">
-              <a:buNone/>
-            </a:pPr>
-            <a:r>
-              <a:rPr lang="ar-SA" altLang="en-US" sz="1100" b="1" dirty="0">
-                <a:solidFill>
-                  <a:srgbClr val="3D3935"/>
-                </a:solidFill>
-                <a:latin typeface="Arial" pitchFamily="34" charset="0"/>
-                <a:ea typeface="Arial" pitchFamily="34" charset="-122"/>
-                <a:cs typeface="Arial" pitchFamily="34" charset="-120"/>
-              </a:rPr>
-              <a:t>أعمال الخرسانة لأعمدة H-Beam</a:t>
-            </a:r>
-            <a:endParaRPr lang="ar-SA" sz="1100" dirty="0"/>
-          </a:p>
-        </p:txBody>
-      </p:sp>
-      <p:sp>
-        <p:nvSpPr>
-          <p:cNvPr id="21" name="Text 19"/>
-          <p:cNvSpPr/>
-          <p:nvPr/>
-        </p:nvSpPr>
-        <p:spPr>
-          <a:xfrm>
-            <a:off x="5251582" y="2542032"/>
-            <a:ext cx="1606235" cy="228600"/>
-          </a:xfrm>
-          <a:prstGeom prst="rect">
-            <a:avLst/>
-          </a:prstGeom>
-          <a:noFill/>
-          <a:ln/>
-        </p:spPr>
-        <p:txBody>
-          <a:bodyPr wrap="square" lIns="0" tIns="0" rIns="0" bIns="0" rtlCol="0" anchor="t">
-            <a:normAutofit/>
-          </a:bodyPr>
-          <a:lstStyle/>
-          <a:p>
-            <a:pPr rtl="1" algn="r" indent="0" marL="0">
-              <a:buNone/>
-            </a:pPr>
-            <a:r>
-              <a:rPr lang="ar-SA" altLang="en-US" sz="750" b="1" dirty="0">
-                <a:solidFill>
-                  <a:srgbClr val="7A3A30"/>
-                </a:solidFill>
-                <a:latin typeface="Arial" pitchFamily="34" charset="0"/>
-                <a:ea typeface="Arial" pitchFamily="34" charset="-122"/>
-                <a:cs typeface="Arial" pitchFamily="34" charset="-120"/>
-              </a:rPr>
-              <a:t>15 أكتوبر → 18 أكتوبر · 3 يوم · A2 SS +1</a:t>
-            </a:r>
-            <a:endParaRPr lang="ar-SA" sz="750" dirty="0"/>
-          </a:p>
-        </p:txBody>
-      </p:sp>
-      <p:sp>
-        <p:nvSpPr>
-          <p:cNvPr id="22" name="Shape 20"/>
-          <p:cNvSpPr/>
-          <p:nvPr/>
-        </p:nvSpPr>
-        <p:spPr>
-          <a:xfrm flipH="1">
-            <a:off x="2584643" y="1783080"/>
-            <a:ext cx="2365187" cy="1051560"/>
-          </a:xfrm>
-          <a:prstGeom prst="chevron">
-            <a:avLst/>
-          </a:prstGeom>
-          <a:solidFill>
-            <a:srgbClr val="F4DAD6"/>
-          </a:solidFill>
-          <a:ln w="12700">
-            <a:solidFill>
-              <a:srgbClr val="F4DAD6"/>
-            </a:solidFill>
-            <a:prstDash val="solid"/>
-          </a:ln>
-        </p:spPr>
-      </p:sp>
-      <p:sp>
-        <p:nvSpPr>
-          <p:cNvPr id="23" name="Shape 21"/>
-          <p:cNvSpPr/>
-          <p:nvPr/>
-        </p:nvSpPr>
-        <p:spPr>
-          <a:xfrm>
-            <a:off x="4309750" y="1874520"/>
-            <a:ext cx="274320" cy="274320"/>
-          </a:xfrm>
-          <a:prstGeom prst="ellipse">
-            <a:avLst/>
-          </a:prstGeom>
-          <a:solidFill>
-            <a:srgbClr val="C8503F"/>
-          </a:solidFill>
-          <a:ln w="12700">
-            <a:solidFill>
-              <a:srgbClr val="C8503F"/>
-            </a:solidFill>
-            <a:prstDash val="solid"/>
-          </a:ln>
-        </p:spPr>
-      </p:sp>
-      <p:sp>
-        <p:nvSpPr>
-          <p:cNvPr id="24" name="Text 22"/>
-          <p:cNvSpPr/>
-          <p:nvPr/>
-        </p:nvSpPr>
-        <p:spPr>
-          <a:xfrm>
-            <a:off x="4309750" y="1874520"/>
-            <a:ext cx="274320" cy="274320"/>
-          </a:xfrm>
-          <a:prstGeom prst="rect">
-            <a:avLst/>
-          </a:prstGeom>
-          <a:noFill/>
-          <a:ln/>
-        </p:spPr>
-        <p:txBody>
-          <a:bodyPr wrap="square" lIns="0" tIns="0" rIns="0" bIns="0" rtlCol="0" anchor="ctr">
-            <a:normAutofit/>
-          </a:bodyPr>
-          <a:lstStyle/>
-          <a:p>
-            <a:pPr rtl="1" algn="ctr" indent="0" marL="0">
-              <a:buNone/>
-            </a:pPr>
-            <a:r>
-              <a:rPr lang="ar-SA" altLang="en-US" sz="1000" b="1" dirty="0">
-                <a:solidFill>
-                  <a:srgbClr val="FFFFFF"/>
-                </a:solidFill>
-                <a:latin typeface="Arial" pitchFamily="34" charset="0"/>
-                <a:ea typeface="Arial" pitchFamily="34" charset="-122"/>
-                <a:cs typeface="Arial" pitchFamily="34" charset="-120"/>
-              </a:rPr>
-              <a:t>4</a:t>
-            </a:r>
-            <a:endParaRPr lang="ar-SA" sz="1000" dirty="0"/>
-          </a:p>
-        </p:txBody>
-      </p:sp>
-      <p:sp>
-        <p:nvSpPr>
-          <p:cNvPr id="25" name="Text 23"/>
-          <p:cNvSpPr/>
-          <p:nvPr/>
-        </p:nvSpPr>
-        <p:spPr>
-          <a:xfrm>
-            <a:off x="2959547" y="2157984"/>
-            <a:ext cx="1606235" cy="411480"/>
-          </a:xfrm>
-          <a:prstGeom prst="rect">
-            <a:avLst/>
-          </a:prstGeom>
-          <a:noFill/>
-          <a:ln/>
-        </p:spPr>
-        <p:txBody>
-          <a:bodyPr wrap="square" lIns="0" tIns="0" rIns="0" bIns="0" rtlCol="0" anchor="t">
-            <a:normAutofit/>
-          </a:bodyPr>
-          <a:lstStyle/>
-          <a:p>
-            <a:pPr rtl="1" algn="r" indent="0" marL="0">
-              <a:buNone/>
-            </a:pPr>
-            <a:r>
-              <a:rPr lang="ar-SA" altLang="en-US" sz="1100" b="1" dirty="0">
-                <a:solidFill>
-                  <a:srgbClr val="3D3935"/>
-                </a:solidFill>
-                <a:latin typeface="Arial" pitchFamily="34" charset="0"/>
-                <a:ea typeface="Arial" pitchFamily="34" charset="-122"/>
-                <a:cs typeface="Arial" pitchFamily="34" charset="-120"/>
-              </a:rPr>
-              <a:t>التدعيم (Bracing) لنظام الدعم</a:t>
-            </a:r>
-            <a:endParaRPr lang="ar-SA" sz="1100" dirty="0"/>
-          </a:p>
-        </p:txBody>
-      </p:sp>
-      <p:sp>
-        <p:nvSpPr>
-          <p:cNvPr id="26" name="Text 24"/>
-          <p:cNvSpPr/>
-          <p:nvPr/>
-        </p:nvSpPr>
-        <p:spPr>
-          <a:xfrm>
-            <a:off x="2959547" y="2542032"/>
-            <a:ext cx="1606235" cy="228600"/>
-          </a:xfrm>
-          <a:prstGeom prst="rect">
-            <a:avLst/>
-          </a:prstGeom>
-          <a:noFill/>
-          <a:ln/>
-        </p:spPr>
-        <p:txBody>
-          <a:bodyPr wrap="square" lIns="0" tIns="0" rIns="0" bIns="0" rtlCol="0" anchor="t">
-            <a:normAutofit/>
-          </a:bodyPr>
-          <a:lstStyle/>
-          <a:p>
-            <a:pPr rtl="1" algn="r" indent="0" marL="0">
-              <a:buNone/>
-            </a:pPr>
-            <a:r>
-              <a:rPr lang="ar-SA" altLang="en-US" sz="750" b="1" dirty="0">
-                <a:solidFill>
-                  <a:srgbClr val="7A3A30"/>
-                </a:solidFill>
-                <a:latin typeface="Arial" pitchFamily="34" charset="0"/>
-                <a:ea typeface="Arial" pitchFamily="34" charset="-122"/>
-                <a:cs typeface="Arial" pitchFamily="34" charset="-120"/>
-              </a:rPr>
-              <a:t>17 أكتوبر → 19 أكتوبر · 3 يوم · A3 SS +1</a:t>
-            </a:r>
-            <a:endParaRPr lang="ar-SA" sz="750" dirty="0"/>
-          </a:p>
-        </p:txBody>
-      </p:sp>
-      <p:sp>
-        <p:nvSpPr>
-          <p:cNvPr id="27" name="Shape 25"/>
-          <p:cNvSpPr/>
-          <p:nvPr/>
-        </p:nvSpPr>
-        <p:spPr>
-          <a:xfrm flipH="1">
-            <a:off x="292608" y="1783080"/>
-            <a:ext cx="2365187" cy="1051560"/>
-          </a:xfrm>
-          <a:prstGeom prst="chevron">
-            <a:avLst/>
-          </a:prstGeom>
-          <a:solidFill>
-            <a:srgbClr val="F4DAD6"/>
-          </a:solidFill>
-          <a:ln w="12700">
-            <a:solidFill>
-              <a:srgbClr val="F4DAD6"/>
-            </a:solidFill>
-            <a:prstDash val="solid"/>
-          </a:ln>
-        </p:spPr>
-      </p:sp>
-      <p:sp>
-        <p:nvSpPr>
-          <p:cNvPr id="28" name="Shape 26"/>
-          <p:cNvSpPr/>
-          <p:nvPr/>
-        </p:nvSpPr>
-        <p:spPr>
-          <a:xfrm>
-            <a:off x="2017715" y="1874520"/>
-            <a:ext cx="274320" cy="274320"/>
-          </a:xfrm>
-          <a:prstGeom prst="ellipse">
-            <a:avLst/>
-          </a:prstGeom>
-          <a:solidFill>
-            <a:srgbClr val="C8503F"/>
-          </a:solidFill>
-          <a:ln w="12700">
-            <a:solidFill>
-              <a:srgbClr val="C8503F"/>
-            </a:solidFill>
-            <a:prstDash val="solid"/>
-          </a:ln>
-        </p:spPr>
-      </p:sp>
-      <p:sp>
-        <p:nvSpPr>
-          <p:cNvPr id="29" name="Text 27"/>
-          <p:cNvSpPr/>
-          <p:nvPr/>
-        </p:nvSpPr>
-        <p:spPr>
-          <a:xfrm>
-            <a:off x="2017715" y="1874520"/>
-            <a:ext cx="274320" cy="274320"/>
-          </a:xfrm>
-          <a:prstGeom prst="rect">
-            <a:avLst/>
-          </a:prstGeom>
-          <a:noFill/>
-          <a:ln/>
-        </p:spPr>
-        <p:txBody>
-          <a:bodyPr wrap="square" lIns="0" tIns="0" rIns="0" bIns="0" rtlCol="0" anchor="ctr">
-            <a:normAutofit/>
-          </a:bodyPr>
-          <a:lstStyle/>
-          <a:p>
-            <a:pPr rtl="1" algn="ctr" indent="0" marL="0">
-              <a:buNone/>
-            </a:pPr>
-            <a:r>
-              <a:rPr lang="ar-SA" altLang="en-US" sz="1000" b="1" dirty="0">
-                <a:solidFill>
-                  <a:srgbClr val="FFFFFF"/>
-                </a:solidFill>
-                <a:latin typeface="Arial" pitchFamily="34" charset="0"/>
-                <a:ea typeface="Arial" pitchFamily="34" charset="-122"/>
-                <a:cs typeface="Arial" pitchFamily="34" charset="-120"/>
-              </a:rPr>
-              <a:t>5</a:t>
-            </a:r>
-            <a:endParaRPr lang="ar-SA" sz="1000" dirty="0"/>
-          </a:p>
-        </p:txBody>
-      </p:sp>
-      <p:sp>
-        <p:nvSpPr>
-          <p:cNvPr id="30" name="Text 28"/>
-          <p:cNvSpPr/>
-          <p:nvPr/>
-        </p:nvSpPr>
-        <p:spPr>
-          <a:xfrm>
-            <a:off x="667512" y="2157984"/>
-            <a:ext cx="1606235" cy="411480"/>
-          </a:xfrm>
-          <a:prstGeom prst="rect">
-            <a:avLst/>
-          </a:prstGeom>
-          <a:noFill/>
-          <a:ln/>
-        </p:spPr>
-        <p:txBody>
-          <a:bodyPr wrap="square" lIns="0" tIns="0" rIns="0" bIns="0" rtlCol="0" anchor="t">
-            <a:normAutofit/>
-          </a:bodyPr>
-          <a:lstStyle/>
-          <a:p>
-            <a:pPr rtl="1" algn="r" indent="0" marL="0">
-              <a:buNone/>
-            </a:pPr>
-            <a:r>
-              <a:rPr lang="ar-SA" altLang="en-US" sz="1100" b="1" dirty="0">
-                <a:solidFill>
-                  <a:srgbClr val="3D3935"/>
-                </a:solidFill>
-                <a:latin typeface="Arial" pitchFamily="34" charset="0"/>
-                <a:ea typeface="Arial" pitchFamily="34" charset="-122"/>
-                <a:cs typeface="Arial" pitchFamily="34" charset="-120"/>
-              </a:rPr>
-              <a:t>تركيب / إدخال الألواح المضلعة (Corrugated sheets)</a:t>
-            </a:r>
-            <a:endParaRPr lang="ar-SA" sz="1100" dirty="0"/>
-          </a:p>
-        </p:txBody>
-      </p:sp>
-      <p:sp>
-        <p:nvSpPr>
-          <p:cNvPr id="31" name="Text 29"/>
-          <p:cNvSpPr/>
-          <p:nvPr/>
-        </p:nvSpPr>
-        <p:spPr>
-          <a:xfrm>
-            <a:off x="667512" y="2542032"/>
-            <a:ext cx="1606235" cy="228600"/>
-          </a:xfrm>
-          <a:prstGeom prst="rect">
-            <a:avLst/>
-          </a:prstGeom>
-          <a:noFill/>
-          <a:ln/>
-        </p:spPr>
-        <p:txBody>
-          <a:bodyPr wrap="square" lIns="0" tIns="0" rIns="0" bIns="0" rtlCol="0" anchor="t">
-            <a:normAutofit/>
-          </a:bodyPr>
-          <a:lstStyle/>
-          <a:p>
-            <a:pPr rtl="1" algn="r" indent="0" marL="0">
-              <a:buNone/>
-            </a:pPr>
-            <a:r>
-              <a:rPr lang="ar-SA" altLang="en-US" sz="750" b="1" dirty="0">
-                <a:solidFill>
-                  <a:srgbClr val="7A3A30"/>
-                </a:solidFill>
-                <a:latin typeface="Arial" pitchFamily="34" charset="0"/>
-                <a:ea typeface="Arial" pitchFamily="34" charset="-122"/>
-                <a:cs typeface="Arial" pitchFamily="34" charset="-120"/>
-              </a:rPr>
-              <a:t>18 أكتوبر → 19 أكتوبر · 2 يوم · A4 SS +1</a:t>
-            </a:r>
-            <a:endParaRPr lang="ar-SA" sz="750" dirty="0"/>
-          </a:p>
-        </p:txBody>
-      </p:sp>
-      <p:sp>
-        <p:nvSpPr>
-          <p:cNvPr id="32" name="Text 30"/>
-          <p:cNvSpPr/>
-          <p:nvPr/>
-        </p:nvSpPr>
-        <p:spPr>
-          <a:xfrm>
-            <a:off x="365760" y="2852928"/>
-            <a:ext cx="11460175" cy="182880"/>
-          </a:xfrm>
-          <a:prstGeom prst="rect">
-            <a:avLst/>
-          </a:prstGeom>
-          <a:noFill/>
-          <a:ln/>
-        </p:spPr>
-        <p:txBody>
-          <a:bodyPr wrap="square" lIns="0" tIns="0" rIns="0" bIns="0" rtlCol="0" anchor="ctr">
-            <a:normAutofit/>
-          </a:bodyPr>
-          <a:lstStyle/>
-          <a:p>
-            <a:pPr rtl="1" algn="r" indent="0" marL="0">
-              <a:buNone/>
-            </a:pPr>
-            <a:r>
-              <a:rPr lang="ar-SA" altLang="en-US" sz="750" dirty="0">
-                <a:solidFill>
-                  <a:srgbClr val="66707A"/>
-                </a:solidFill>
-                <a:latin typeface="Arial" pitchFamily="34" charset="0"/>
-                <a:ea typeface="Arial" pitchFamily="34" charset="-122"/>
-                <a:cs typeface="Arial" pitchFamily="34" charset="-120"/>
-              </a:rPr>
-              <a:t>مدد وعلاقات الأنشطة الخمسة الفرعية مقترحة لتقع ضمن 6 أيام عمل للنشاط A (قابلة للتعديل).</a:t>
-            </a:r>
-            <a:endParaRPr lang="ar-SA" sz="750" dirty="0"/>
-          </a:p>
-        </p:txBody>
-      </p:sp>
-      <p:sp>
-        <p:nvSpPr>
-          <p:cNvPr id="33" name="Shape 31"/>
-          <p:cNvSpPr/>
-          <p:nvPr/>
-        </p:nvSpPr>
-        <p:spPr>
-          <a:xfrm>
-            <a:off x="11771071" y="3099816"/>
-            <a:ext cx="54864" cy="256032"/>
-          </a:xfrm>
-          <a:prstGeom prst="rect">
-            <a:avLst/>
-          </a:prstGeom>
-          <a:solidFill>
-            <a:srgbClr val="00778B"/>
-          </a:solidFill>
-          <a:ln w="12700">
-            <a:solidFill>
-              <a:srgbClr val="00778B"/>
-            </a:solidFill>
-            <a:prstDash val="solid"/>
-          </a:ln>
-        </p:spPr>
-      </p:sp>
-      <p:sp>
-        <p:nvSpPr>
-          <p:cNvPr id="34" name="Text 32"/>
-          <p:cNvSpPr/>
-          <p:nvPr/>
-        </p:nvSpPr>
-        <p:spPr>
-          <a:xfrm>
-            <a:off x="8022031" y="3063240"/>
-            <a:ext cx="3657600" cy="329184"/>
-          </a:xfrm>
-          <a:prstGeom prst="rect">
-            <a:avLst/>
-          </a:prstGeom>
-          <a:noFill/>
-          <a:ln/>
-        </p:spPr>
-        <p:txBody>
-          <a:bodyPr wrap="square" lIns="0" tIns="0" rIns="0" bIns="0" rtlCol="0" anchor="ctr">
-            <a:normAutofit/>
-          </a:bodyPr>
-          <a:lstStyle/>
-          <a:p>
-            <a:pPr rtl="1" algn="r" indent="0" marL="0">
-              <a:buNone/>
-            </a:pPr>
-            <a:r>
-              <a:rPr lang="ar-SA" altLang="en-US" sz="1500" b="1" dirty="0">
-                <a:solidFill>
-                  <a:srgbClr val="3D3935"/>
-                </a:solidFill>
-                <a:latin typeface="Arial" pitchFamily="34" charset="0"/>
-                <a:ea typeface="Arial" pitchFamily="34" charset="-122"/>
-                <a:cs typeface="Arial" pitchFamily="34" charset="-120"/>
-              </a:rPr>
-              <a:t>التواريخ الرئيسية (تلقائية)</a:t>
-            </a:r>
-            <a:endParaRPr lang="ar-SA" sz="1500" dirty="0"/>
-          </a:p>
-        </p:txBody>
-      </p:sp>
-      <p:sp>
-        <p:nvSpPr>
-          <p:cNvPr id="35" name="Shape 33"/>
-          <p:cNvSpPr/>
-          <p:nvPr/>
-        </p:nvSpPr>
-        <p:spPr>
-          <a:xfrm>
-            <a:off x="7619695" y="3493008"/>
-            <a:ext cx="4206240" cy="310896"/>
-          </a:xfrm>
-          <a:prstGeom prst="rect">
-            <a:avLst/>
-          </a:prstGeom>
-          <a:solidFill>
-            <a:srgbClr val="FFFFFF"/>
-          </a:solidFill>
-          <a:ln w="6350">
-            <a:solidFill>
-              <a:srgbClr val="DFE6EA"/>
-            </a:solidFill>
-            <a:prstDash val="solid"/>
-          </a:ln>
-        </p:spPr>
-      </p:sp>
-      <p:sp>
-        <p:nvSpPr>
-          <p:cNvPr id="36" name="Text 34"/>
-          <p:cNvSpPr/>
-          <p:nvPr/>
-        </p:nvSpPr>
-        <p:spPr>
-          <a:xfrm>
-            <a:off x="9448495" y="3493008"/>
-            <a:ext cx="2286000" cy="310896"/>
-          </a:xfrm>
-          <a:prstGeom prst="rect">
-            <a:avLst/>
-          </a:prstGeom>
-          <a:noFill/>
-          <a:ln/>
-        </p:spPr>
-        <p:txBody>
-          <a:bodyPr wrap="square" lIns="0" tIns="0" rIns="0" bIns="0" rtlCol="0" anchor="ctr">
-            <a:normAutofit/>
-          </a:bodyPr>
-          <a:lstStyle/>
-          <a:p>
-            <a:pPr rtl="1" algn="r" indent="0" marL="0">
-              <a:buNone/>
-            </a:pPr>
-            <a:r>
-              <a:rPr lang="ar-SA" altLang="en-US" sz="950" dirty="0">
-                <a:solidFill>
-                  <a:srgbClr val="4A555D"/>
-                </a:solidFill>
-                <a:latin typeface="Arial" pitchFamily="34" charset="0"/>
-                <a:ea typeface="Arial" pitchFamily="34" charset="-122"/>
-                <a:cs typeface="Arial" pitchFamily="34" charset="-120"/>
-              </a:rPr>
-              <a:t>بدء الأعمال</a:t>
-            </a:r>
-            <a:endParaRPr lang="ar-SA" sz="950" dirty="0"/>
-          </a:p>
-        </p:txBody>
-      </p:sp>
-      <p:sp>
-        <p:nvSpPr>
-          <p:cNvPr id="37" name="Text 35"/>
-          <p:cNvSpPr/>
-          <p:nvPr/>
-        </p:nvSpPr>
-        <p:spPr>
-          <a:xfrm>
-            <a:off x="7711135" y="3493008"/>
-            <a:ext cx="1828800" cy="310896"/>
-          </a:xfrm>
-          <a:prstGeom prst="rect">
-            <a:avLst/>
-          </a:prstGeom>
-          <a:noFill/>
-          <a:ln/>
-        </p:spPr>
-        <p:txBody>
-          <a:bodyPr wrap="square" lIns="0" tIns="0" rIns="0" bIns="0" rtlCol="0" anchor="ctr">
-            <a:normAutofit/>
-          </a:bodyPr>
-          <a:lstStyle/>
-          <a:p>
-            <a:pPr rtl="1" algn="l" indent="0" marL="0">
-              <a:buNone/>
-            </a:pPr>
-            <a:r>
-              <a:rPr lang="ar-SA" altLang="en-US" sz="950" b="1" dirty="0">
-                <a:solidFill>
-                  <a:srgbClr val="3D3935"/>
-                </a:solidFill>
-                <a:latin typeface="Arial" pitchFamily="34" charset="0"/>
-                <a:ea typeface="Arial" pitchFamily="34" charset="-122"/>
-                <a:cs typeface="Arial" pitchFamily="34" charset="-120"/>
-              </a:rPr>
-              <a:t>ثلاثاء 13 أكتوبر 2026</a:t>
-            </a:r>
-            <a:endParaRPr lang="ar-SA" sz="950" dirty="0"/>
-          </a:p>
-        </p:txBody>
-      </p:sp>
-      <p:sp>
-        <p:nvSpPr>
-          <p:cNvPr id="38" name="Shape 36"/>
-          <p:cNvSpPr/>
-          <p:nvPr/>
-        </p:nvSpPr>
-        <p:spPr>
-          <a:xfrm>
-            <a:off x="7619695" y="3803904"/>
-            <a:ext cx="4206240" cy="310896"/>
-          </a:xfrm>
-          <a:prstGeom prst="rect">
-            <a:avLst/>
-          </a:prstGeom>
-          <a:solidFill>
-            <a:srgbClr val="F6F9FA"/>
-          </a:solidFill>
-          <a:ln w="6350">
-            <a:solidFill>
-              <a:srgbClr val="DFE6EA"/>
-            </a:solidFill>
-            <a:prstDash val="solid"/>
-          </a:ln>
-        </p:spPr>
-      </p:sp>
-      <p:sp>
-        <p:nvSpPr>
-          <p:cNvPr id="39" name="Text 37"/>
-          <p:cNvSpPr/>
-          <p:nvPr/>
-        </p:nvSpPr>
-        <p:spPr>
-          <a:xfrm>
-            <a:off x="9448495" y="3803904"/>
-            <a:ext cx="2286000" cy="310896"/>
-          </a:xfrm>
-          <a:prstGeom prst="rect">
-            <a:avLst/>
-          </a:prstGeom>
-          <a:noFill/>
-          <a:ln/>
-        </p:spPr>
-        <p:txBody>
-          <a:bodyPr wrap="square" lIns="0" tIns="0" rIns="0" bIns="0" rtlCol="0" anchor="ctr">
-            <a:normAutofit/>
-          </a:bodyPr>
-          <a:lstStyle/>
-          <a:p>
-            <a:pPr rtl="1" algn="r" indent="0" marL="0">
-              <a:buNone/>
-            </a:pPr>
-            <a:r>
-              <a:rPr lang="ar-SA" altLang="en-US" sz="950" dirty="0">
-                <a:solidFill>
-                  <a:srgbClr val="4A555D"/>
-                </a:solidFill>
-                <a:latin typeface="Arial" pitchFamily="34" charset="0"/>
-                <a:ea typeface="Arial" pitchFamily="34" charset="-122"/>
-                <a:cs typeface="Arial" pitchFamily="34" charset="-120"/>
-              </a:rPr>
-              <a:t>اكتمال تركيب نظام الدعم</a:t>
-            </a:r>
-            <a:endParaRPr lang="ar-SA" sz="950" dirty="0"/>
-          </a:p>
-        </p:txBody>
-      </p:sp>
-      <p:sp>
-        <p:nvSpPr>
-          <p:cNvPr id="40" name="Text 38"/>
-          <p:cNvSpPr/>
-          <p:nvPr/>
-        </p:nvSpPr>
-        <p:spPr>
-          <a:xfrm>
-            <a:off x="7711135" y="3803904"/>
-            <a:ext cx="1828800" cy="310896"/>
-          </a:xfrm>
-          <a:prstGeom prst="rect">
-            <a:avLst/>
-          </a:prstGeom>
-          <a:noFill/>
-          <a:ln/>
-        </p:spPr>
-        <p:txBody>
-          <a:bodyPr wrap="square" lIns="0" tIns="0" rIns="0" bIns="0" rtlCol="0" anchor="ctr">
-            <a:normAutofit/>
-          </a:bodyPr>
-          <a:lstStyle/>
-          <a:p>
-            <a:pPr rtl="1" algn="l" indent="0" marL="0">
-              <a:buNone/>
-            </a:pPr>
-            <a:r>
-              <a:rPr lang="ar-SA" altLang="en-US" sz="950" b="1" dirty="0">
-                <a:solidFill>
-                  <a:srgbClr val="3D3935"/>
-                </a:solidFill>
-                <a:latin typeface="Arial" pitchFamily="34" charset="0"/>
-                <a:ea typeface="Arial" pitchFamily="34" charset="-122"/>
-                <a:cs typeface="Arial" pitchFamily="34" charset="-120"/>
-              </a:rPr>
-              <a:t>اثنين 19 أكتوبر 2026</a:t>
-            </a:r>
-            <a:endParaRPr lang="ar-SA" sz="950" dirty="0"/>
-          </a:p>
-        </p:txBody>
-      </p:sp>
-      <p:sp>
-        <p:nvSpPr>
-          <p:cNvPr id="41" name="Shape 39"/>
-          <p:cNvSpPr/>
-          <p:nvPr/>
-        </p:nvSpPr>
-        <p:spPr>
-          <a:xfrm>
-            <a:off x="7619695" y="4114800"/>
-            <a:ext cx="4206240" cy="310896"/>
-          </a:xfrm>
-          <a:prstGeom prst="rect">
-            <a:avLst/>
-          </a:prstGeom>
-          <a:solidFill>
-            <a:srgbClr val="FFFFFF"/>
-          </a:solidFill>
-          <a:ln w="6350">
-            <a:solidFill>
-              <a:srgbClr val="DFE6EA"/>
-            </a:solidFill>
-            <a:prstDash val="solid"/>
-          </a:ln>
-        </p:spPr>
-      </p:sp>
-      <p:sp>
-        <p:nvSpPr>
-          <p:cNvPr id="42" name="Text 40"/>
-          <p:cNvSpPr/>
-          <p:nvPr/>
-        </p:nvSpPr>
-        <p:spPr>
-          <a:xfrm>
-            <a:off x="9448495" y="4114800"/>
-            <a:ext cx="2286000" cy="310896"/>
-          </a:xfrm>
-          <a:prstGeom prst="rect">
-            <a:avLst/>
-          </a:prstGeom>
-          <a:noFill/>
-          <a:ln/>
-        </p:spPr>
-        <p:txBody>
-          <a:bodyPr wrap="square" lIns="0" tIns="0" rIns="0" bIns="0" rtlCol="0" anchor="ctr">
-            <a:normAutofit/>
-          </a:bodyPr>
-          <a:lstStyle/>
-          <a:p>
-            <a:pPr rtl="1" algn="r" indent="0" marL="0">
-              <a:buNone/>
-            </a:pPr>
-            <a:r>
-              <a:rPr lang="ar-SA" altLang="en-US" sz="950" dirty="0">
-                <a:solidFill>
-                  <a:srgbClr val="4A555D"/>
-                </a:solidFill>
-                <a:latin typeface="Arial" pitchFamily="34" charset="0"/>
-                <a:ea typeface="Arial" pitchFamily="34" charset="-122"/>
-                <a:cs typeface="Arial" pitchFamily="34" charset="-120"/>
-              </a:rPr>
-              <a:t>اكتمال أعمال الحفرة (جدار الحفرة)</a:t>
-            </a:r>
-            <a:endParaRPr lang="ar-SA" sz="950" dirty="0"/>
-          </a:p>
-        </p:txBody>
-      </p:sp>
-      <p:sp>
-        <p:nvSpPr>
-          <p:cNvPr id="43" name="Text 41"/>
-          <p:cNvSpPr/>
-          <p:nvPr/>
-        </p:nvSpPr>
-        <p:spPr>
-          <a:xfrm>
-            <a:off x="7711135" y="4114800"/>
-            <a:ext cx="1828800" cy="310896"/>
-          </a:xfrm>
-          <a:prstGeom prst="rect">
-            <a:avLst/>
-          </a:prstGeom>
-          <a:noFill/>
-          <a:ln/>
-        </p:spPr>
-        <p:txBody>
-          <a:bodyPr wrap="square" lIns="0" tIns="0" rIns="0" bIns="0" rtlCol="0" anchor="ctr">
-            <a:normAutofit/>
-          </a:bodyPr>
-          <a:lstStyle/>
-          <a:p>
-            <a:pPr rtl="1" algn="l" indent="0" marL="0">
-              <a:buNone/>
-            </a:pPr>
-            <a:r>
-              <a:rPr lang="ar-SA" altLang="en-US" sz="950" b="1" dirty="0">
-                <a:solidFill>
-                  <a:srgbClr val="3D3935"/>
-                </a:solidFill>
-                <a:latin typeface="Arial" pitchFamily="34" charset="0"/>
-                <a:ea typeface="Arial" pitchFamily="34" charset="-122"/>
-                <a:cs typeface="Arial" pitchFamily="34" charset="-120"/>
-              </a:rPr>
-              <a:t>أربعاء 11 نوفمبر 2026</a:t>
-            </a:r>
-            <a:endParaRPr lang="ar-SA" sz="950" dirty="0"/>
-          </a:p>
-        </p:txBody>
-      </p:sp>
-      <p:sp>
-        <p:nvSpPr>
-          <p:cNvPr id="44" name="Shape 42"/>
-          <p:cNvSpPr/>
-          <p:nvPr/>
-        </p:nvSpPr>
-        <p:spPr>
-          <a:xfrm>
-            <a:off x="7619695" y="4425696"/>
-            <a:ext cx="4206240" cy="310896"/>
-          </a:xfrm>
-          <a:prstGeom prst="rect">
-            <a:avLst/>
-          </a:prstGeom>
-          <a:solidFill>
-            <a:srgbClr val="F6F9FA"/>
-          </a:solidFill>
-          <a:ln w="6350">
-            <a:solidFill>
-              <a:srgbClr val="DFE6EA"/>
-            </a:solidFill>
-            <a:prstDash val="solid"/>
-          </a:ln>
-        </p:spPr>
-      </p:sp>
-      <p:sp>
-        <p:nvSpPr>
-          <p:cNvPr id="45" name="Text 43"/>
-          <p:cNvSpPr/>
-          <p:nvPr/>
-        </p:nvSpPr>
-        <p:spPr>
-          <a:xfrm>
-            <a:off x="9448495" y="4425696"/>
-            <a:ext cx="2286000" cy="310896"/>
-          </a:xfrm>
-          <a:prstGeom prst="rect">
-            <a:avLst/>
-          </a:prstGeom>
-          <a:noFill/>
-          <a:ln/>
-        </p:spPr>
-        <p:txBody>
-          <a:bodyPr wrap="square" lIns="0" tIns="0" rIns="0" bIns="0" rtlCol="0" anchor="ctr">
-            <a:normAutofit/>
-          </a:bodyPr>
-          <a:lstStyle/>
-          <a:p>
-            <a:pPr rtl="1" algn="r" indent="0" marL="0">
-              <a:buNone/>
-            </a:pPr>
-            <a:r>
-              <a:rPr lang="ar-SA" altLang="en-US" sz="950" dirty="0">
-                <a:solidFill>
-                  <a:srgbClr val="4A555D"/>
-                </a:solidFill>
-                <a:latin typeface="Arial" pitchFamily="34" charset="0"/>
-                <a:ea typeface="Arial" pitchFamily="34" charset="-122"/>
-                <a:cs typeface="Arial" pitchFamily="34" charset="-120"/>
-              </a:rPr>
-              <a:t>اكتمال أساسات المبنى</a:t>
-            </a:r>
-            <a:endParaRPr lang="ar-SA" sz="950" dirty="0"/>
-          </a:p>
-        </p:txBody>
-      </p:sp>
-      <p:sp>
-        <p:nvSpPr>
-          <p:cNvPr id="46" name="Text 44"/>
-          <p:cNvSpPr/>
-          <p:nvPr/>
-        </p:nvSpPr>
-        <p:spPr>
-          <a:xfrm>
-            <a:off x="7711135" y="4425696"/>
-            <a:ext cx="1828800" cy="310896"/>
-          </a:xfrm>
-          <a:prstGeom prst="rect">
-            <a:avLst/>
-          </a:prstGeom>
-          <a:noFill/>
-          <a:ln/>
-        </p:spPr>
-        <p:txBody>
-          <a:bodyPr wrap="square" lIns="0" tIns="0" rIns="0" bIns="0" rtlCol="0" anchor="ctr">
-            <a:normAutofit/>
-          </a:bodyPr>
-          <a:lstStyle/>
-          <a:p>
-            <a:pPr rtl="1" algn="l" indent="0" marL="0">
-              <a:buNone/>
-            </a:pPr>
-            <a:r>
-              <a:rPr lang="ar-SA" altLang="en-US" sz="950" b="1" dirty="0">
-                <a:solidFill>
-                  <a:srgbClr val="3D3935"/>
-                </a:solidFill>
-                <a:latin typeface="Arial" pitchFamily="34" charset="0"/>
-                <a:ea typeface="Arial" pitchFamily="34" charset="-122"/>
-                <a:cs typeface="Arial" pitchFamily="34" charset="-120"/>
-              </a:rPr>
-              <a:t>أربعاء 18 نوفمبر 2026</a:t>
-            </a:r>
-            <a:endParaRPr lang="ar-SA" sz="950" dirty="0"/>
-          </a:p>
-        </p:txBody>
-      </p:sp>
-      <p:sp>
-        <p:nvSpPr>
-          <p:cNvPr id="47" name="Shape 45"/>
-          <p:cNvSpPr/>
-          <p:nvPr/>
-        </p:nvSpPr>
-        <p:spPr>
-          <a:xfrm>
-            <a:off x="7619695" y="4736592"/>
-            <a:ext cx="4206240" cy="310896"/>
-          </a:xfrm>
-          <a:prstGeom prst="rect">
-            <a:avLst/>
-          </a:prstGeom>
-          <a:solidFill>
-            <a:srgbClr val="FFFFFF"/>
-          </a:solidFill>
-          <a:ln w="6350">
-            <a:solidFill>
-              <a:srgbClr val="DFE6EA"/>
-            </a:solidFill>
-            <a:prstDash val="solid"/>
-          </a:ln>
-        </p:spPr>
-      </p:sp>
-      <p:sp>
-        <p:nvSpPr>
-          <p:cNvPr id="48" name="Text 46"/>
-          <p:cNvSpPr/>
-          <p:nvPr/>
-        </p:nvSpPr>
-        <p:spPr>
-          <a:xfrm>
-            <a:off x="9448495" y="4736592"/>
-            <a:ext cx="2286000" cy="310896"/>
-          </a:xfrm>
-          <a:prstGeom prst="rect">
-            <a:avLst/>
-          </a:prstGeom>
-          <a:noFill/>
-          <a:ln/>
-        </p:spPr>
-        <p:txBody>
-          <a:bodyPr wrap="square" lIns="0" tIns="0" rIns="0" bIns="0" rtlCol="0" anchor="ctr">
-            <a:normAutofit/>
-          </a:bodyPr>
-          <a:lstStyle/>
-          <a:p>
-            <a:pPr rtl="1" algn="r" indent="0" marL="0">
-              <a:buNone/>
-            </a:pPr>
-            <a:r>
-              <a:rPr lang="ar-SA" altLang="en-US" sz="950" dirty="0">
-                <a:solidFill>
-                  <a:srgbClr val="4A555D"/>
-                </a:solidFill>
-                <a:latin typeface="Arial" pitchFamily="34" charset="0"/>
-                <a:ea typeface="Arial" pitchFamily="34" charset="-122"/>
-                <a:cs typeface="Arial" pitchFamily="34" charset="-120"/>
-              </a:rPr>
-              <a:t>الإنجاز الكلي</a:t>
-            </a:r>
-            <a:endParaRPr lang="ar-SA" sz="950" dirty="0"/>
-          </a:p>
-        </p:txBody>
-      </p:sp>
-      <p:sp>
-        <p:nvSpPr>
-          <p:cNvPr id="49" name="Text 47"/>
-          <p:cNvSpPr/>
-          <p:nvPr/>
-        </p:nvSpPr>
-        <p:spPr>
-          <a:xfrm>
-            <a:off x="7711135" y="4736592"/>
-            <a:ext cx="1828800" cy="310896"/>
-          </a:xfrm>
-          <a:prstGeom prst="rect">
-            <a:avLst/>
-          </a:prstGeom>
-          <a:noFill/>
-          <a:ln/>
-        </p:spPr>
-        <p:txBody>
-          <a:bodyPr wrap="square" lIns="0" tIns="0" rIns="0" bIns="0" rtlCol="0" anchor="ctr">
-            <a:normAutofit/>
-          </a:bodyPr>
-          <a:lstStyle/>
-          <a:p>
-            <a:pPr rtl="1" algn="l" indent="0" marL="0">
-              <a:buNone/>
-            </a:pPr>
-            <a:r>
-              <a:rPr lang="ar-SA" altLang="en-US" sz="950" b="1" dirty="0">
-                <a:solidFill>
-                  <a:srgbClr val="3D3935"/>
-                </a:solidFill>
-                <a:latin typeface="Arial" pitchFamily="34" charset="0"/>
-                <a:ea typeface="Arial" pitchFamily="34" charset="-122"/>
-                <a:cs typeface="Arial" pitchFamily="34" charset="-120"/>
-              </a:rPr>
-              <a:t>ثلاثاء 24 نوفمبر 2026</a:t>
-            </a:r>
-            <a:endParaRPr lang="ar-SA" sz="950" dirty="0"/>
-          </a:p>
-        </p:txBody>
-      </p:sp>
-      <p:sp>
-        <p:nvSpPr>
-          <p:cNvPr id="50" name="Shape 48"/>
-          <p:cNvSpPr/>
-          <p:nvPr/>
-        </p:nvSpPr>
-        <p:spPr>
-          <a:xfrm>
-            <a:off x="7619695" y="5166360"/>
-            <a:ext cx="4206240" cy="960120"/>
-          </a:xfrm>
-          <a:prstGeom prst="roundRect">
-            <a:avLst>
-              <a:gd name="adj" fmla="val 7619"/>
-            </a:avLst>
-          </a:prstGeom>
-          <a:solidFill>
-            <a:srgbClr val="FFF6E5"/>
-          </a:solidFill>
-          <a:ln w="12700">
-            <a:solidFill>
-              <a:srgbClr val="F0C36D"/>
-            </a:solidFill>
-            <a:prstDash val="solid"/>
-          </a:ln>
-        </p:spPr>
-      </p:sp>
-      <p:sp>
-        <p:nvSpPr>
-          <p:cNvPr id="51" name="Text 49"/>
-          <p:cNvSpPr/>
-          <p:nvPr/>
-        </p:nvSpPr>
-        <p:spPr>
-          <a:xfrm>
-            <a:off x="7756855" y="5212080"/>
-            <a:ext cx="3931920" cy="228600"/>
-          </a:xfrm>
-          <a:prstGeom prst="rect">
-            <a:avLst/>
-          </a:prstGeom>
-          <a:noFill/>
-          <a:ln/>
-        </p:spPr>
-        <p:txBody>
-          <a:bodyPr wrap="square" lIns="0" tIns="0" rIns="0" bIns="0" rtlCol="0" anchor="ctr">
-            <a:normAutofit/>
-          </a:bodyPr>
-          <a:lstStyle/>
-          <a:p>
-            <a:pPr rtl="1" algn="r" indent="0" marL="0">
-              <a:buNone/>
-            </a:pPr>
-            <a:r>
-              <a:rPr lang="ar-SA" altLang="en-US" sz="950" b="1" dirty="0">
-                <a:solidFill>
-                  <a:srgbClr val="9A6A00"/>
-                </a:solidFill>
-                <a:latin typeface="Arial" pitchFamily="34" charset="0"/>
-                <a:ea typeface="Arial" pitchFamily="34" charset="-122"/>
-                <a:cs typeface="Arial" pitchFamily="34" charset="-120"/>
-              </a:rPr>
-              <a:t>سيناريو افتراضي</a:t>
-            </a:r>
-            <a:endParaRPr lang="ar-SA" sz="950" dirty="0"/>
-          </a:p>
-        </p:txBody>
-      </p:sp>
-      <p:sp>
-        <p:nvSpPr>
-          <p:cNvPr id="52" name="Text 50"/>
-          <p:cNvSpPr/>
-          <p:nvPr/>
-        </p:nvSpPr>
-        <p:spPr>
-          <a:xfrm>
-            <a:off x="7756855" y="5440680"/>
-            <a:ext cx="3931920" cy="658368"/>
-          </a:xfrm>
-          <a:prstGeom prst="rect">
-            <a:avLst/>
-          </a:prstGeom>
-          <a:noFill/>
-          <a:ln/>
-        </p:spPr>
-        <p:txBody>
-          <a:bodyPr wrap="square" lIns="0" tIns="0" rIns="0" bIns="0" rtlCol="0" anchor="t">
-            <a:normAutofit/>
-          </a:bodyPr>
-          <a:lstStyle/>
-          <a:p>
-            <a:pPr rtl="1" algn="r" indent="0" marL="0">
-              <a:buNone/>
-            </a:pPr>
-            <a:r>
-              <a:rPr lang="ar-SA" altLang="en-US" sz="950" dirty="0">
-                <a:solidFill>
-                  <a:srgbClr val="3D3935"/>
-                </a:solidFill>
-                <a:latin typeface="Arial" pitchFamily="34" charset="0"/>
-                <a:ea typeface="Arial" pitchFamily="34" charset="-122"/>
-                <a:cs typeface="Arial" pitchFamily="34" charset="-120"/>
-              </a:rPr>
-              <a:t>إذا بدأت الأعمال في 21 أكتوبر 2026 (تاريخ جاهزية التصريح) → فسيكون الإنجاز الكلي 2 ديسمبر 2026 (+8 يوماً (تقويمياً) بعد المقترح).</a:t>
-            </a:r>
-            <a:endParaRPr lang="ar-SA" sz="950" dirty="0"/>
-          </a:p>
-        </p:txBody>
-      </p:sp>
-      <p:sp>
-        <p:nvSpPr>
-          <p:cNvPr id="53" name="Shape 51"/>
-          <p:cNvSpPr/>
-          <p:nvPr/>
-        </p:nvSpPr>
-        <p:spPr>
-          <a:xfrm>
-            <a:off x="7199071" y="3099816"/>
-            <a:ext cx="54864" cy="256032"/>
-          </a:xfrm>
-          <a:prstGeom prst="rect">
-            <a:avLst/>
-          </a:prstGeom>
-          <a:solidFill>
-            <a:srgbClr val="00778B"/>
-          </a:solidFill>
-          <a:ln w="12700">
-            <a:solidFill>
-              <a:srgbClr val="00778B"/>
-            </a:solidFill>
-            <a:prstDash val="solid"/>
-          </a:ln>
-        </p:spPr>
-      </p:sp>
-      <p:sp>
-        <p:nvSpPr>
-          <p:cNvPr id="54" name="Text 52"/>
-          <p:cNvSpPr/>
-          <p:nvPr/>
-        </p:nvSpPr>
-        <p:spPr>
-          <a:xfrm>
-            <a:off x="1621231" y="3063240"/>
-            <a:ext cx="5486400" cy="329184"/>
-          </a:xfrm>
-          <a:prstGeom prst="rect">
-            <a:avLst/>
-          </a:prstGeom>
-          <a:noFill/>
-          <a:ln/>
-        </p:spPr>
-        <p:txBody>
-          <a:bodyPr wrap="square" lIns="0" tIns="0" rIns="0" bIns="0" rtlCol="0" anchor="ctr">
-            <a:normAutofit/>
-          </a:bodyPr>
-          <a:lstStyle/>
-          <a:p>
-            <a:pPr rtl="1" algn="r" indent="0" marL="0">
-              <a:buNone/>
-            </a:pPr>
-            <a:r>
-              <a:rPr lang="ar-SA" altLang="en-US" sz="1500" b="1" dirty="0">
-                <a:solidFill>
-                  <a:srgbClr val="3D3935"/>
-                </a:solidFill>
-                <a:latin typeface="Arial" pitchFamily="34" charset="0"/>
-                <a:ea typeface="Arial" pitchFamily="34" charset="-122"/>
-                <a:cs typeface="Arial" pitchFamily="34" charset="-120"/>
-              </a:rPr>
-              <a:t>ملاحظات وشروط</a:t>
-            </a:r>
-            <a:endParaRPr lang="ar-SA" sz="1500" dirty="0"/>
-          </a:p>
-        </p:txBody>
-      </p:sp>
-      <p:sp>
-        <p:nvSpPr>
-          <p:cNvPr id="55" name="Text 53"/>
-          <p:cNvSpPr/>
-          <p:nvPr/>
-        </p:nvSpPr>
-        <p:spPr>
-          <a:xfrm>
-            <a:off x="395935" y="3474720"/>
-            <a:ext cx="6766560" cy="2697480"/>
-          </a:xfrm>
-          <a:prstGeom prst="rect">
-            <a:avLst/>
-          </a:prstGeom>
-          <a:noFill/>
-          <a:ln/>
-        </p:spPr>
-        <p:txBody>
-          <a:bodyPr wrap="square" lIns="0" tIns="0" rIns="0" bIns="0" rtlCol="0" anchor="t">
-            <a:normAutofit/>
-          </a:bodyPr>
-          <a:lstStyle/>
-          <a:p>
-            <a:pPr algn="r" marL="342900" indent="-342900">
-              <a:spcAft>
-                <a:spcPts val="600"/>
-              </a:spcAft>
-              <a:buSzPct val="100000"/>
-              <a:buFont typeface="+mj-lt"/>
-              <a:buAutoNum type="arabicPeriod" startAt="1"/>
-            </a:pPr>
-            <a:r>
-              <a:rPr lang="ar-SA" altLang="en-US" sz="1050" dirty="0">
-                <a:solidFill>
-                  <a:srgbClr val="333333"/>
-                </a:solidFill>
-                <a:latin typeface="Arial" pitchFamily="34" charset="0"/>
-                <a:ea typeface="Arial" pitchFamily="34" charset="-122"/>
-                <a:cs typeface="Arial" pitchFamily="34" charset="-120"/>
-              </a:rPr>
-              <a:t>بدء كل نشاط مشروط بإصدار تصريح العمل والموافقة في الوقت المناسب على طلبات فحص الأعمال (WIR) وطلبات فحص المواد (MIR). أي تأخير في إصدار التصريح أو اعتماد الطلبات يزيح النشاط المتأثر وكل الأنشطة اللاحقة له.</a:t>
-            </a:r>
-            <a:endParaRPr lang="ar-SA" sz="1050" dirty="0"/>
-          </a:p>
-          <a:p>
-            <a:pPr algn="r" marL="342900" indent="-342900">
-              <a:spcAft>
-                <a:spcPts val="600"/>
-              </a:spcAft>
-              <a:buSzPct val="100000"/>
-              <a:buFont typeface="+mj-lt"/>
-              <a:buAutoNum type="arabicPeriod" startAt="1"/>
-            </a:pPr>
-            <a:r>
-              <a:rPr lang="ar-SA" altLang="en-US" sz="1050" dirty="0">
-                <a:solidFill>
-                  <a:srgbClr val="333333"/>
-                </a:solidFill>
-                <a:latin typeface="Arial" pitchFamily="34" charset="0"/>
-                <a:ea typeface="Arial" pitchFamily="34" charset="-122"/>
-                <a:cs typeface="Arial" pitchFamily="34" charset="-120"/>
-              </a:rPr>
-              <a:t>أسبوع العمل من السبت إلى الخميس، والجمعة إجازة.</a:t>
-            </a:r>
-            <a:endParaRPr lang="ar-SA" sz="1050" dirty="0"/>
-          </a:p>
-          <a:p>
-            <a:pPr algn="r" marL="342900" indent="-342900">
-              <a:spcAft>
-                <a:spcPts val="600"/>
-              </a:spcAft>
-              <a:buSzPct val="100000"/>
-              <a:buFont typeface="+mj-lt"/>
-              <a:buAutoNum type="arabicPeriod" startAt="1"/>
-            </a:pPr>
-            <a:r>
-              <a:rPr lang="ar-SA" altLang="en-US" sz="1050" dirty="0">
-                <a:solidFill>
-                  <a:srgbClr val="333333"/>
-                </a:solidFill>
-                <a:latin typeface="Arial" pitchFamily="34" charset="0"/>
-                <a:ea typeface="Arial" pitchFamily="34" charset="-122"/>
-                <a:cs typeface="Arial" pitchFamily="34" charset="-120"/>
-              </a:rPr>
-              <a:t>الخرسانة العادية تسير بالتوازي مع الدعم (علاقة SS) وتُصب فقط في الأجزاء التي تم تركيب الدعم فيها.</a:t>
-            </a:r>
-            <a:endParaRPr lang="ar-SA" sz="1050" dirty="0"/>
-          </a:p>
-          <a:p>
-            <a:pPr algn="r" marL="342900" indent="-342900">
-              <a:spcAft>
-                <a:spcPts val="600"/>
-              </a:spcAft>
-              <a:buSzPct val="100000"/>
-              <a:buFont typeface="+mj-lt"/>
-              <a:buAutoNum type="arabicPeriod" startAt="1"/>
-            </a:pPr>
-            <a:r>
-              <a:rPr lang="ar-SA" altLang="en-US" sz="1050" dirty="0">
-                <a:solidFill>
-                  <a:srgbClr val="333333"/>
-                </a:solidFill>
-                <a:latin typeface="Arial" pitchFamily="34" charset="0"/>
-                <a:ea typeface="Arial" pitchFamily="34" charset="-122"/>
-                <a:cs typeface="Arial" pitchFamily="34" charset="-120"/>
-              </a:rPr>
-              <a:t>أساسات المبنى مرتبطة بإنجاز بلاطة / لبشة الحفرة (علاقة FS) وتسير بالتوازي مع جدار الحفرة. يمكن تغيير سابقها إلى E إذا لزم أن تلي جدار الحفرة.</a:t>
-            </a:r>
-            <a:endParaRPr lang="ar-SA" sz="1050" dirty="0"/>
-          </a:p>
-        </p:txBody>
-      </p:sp>
-      <p:sp>
-        <p:nvSpPr>
-          <p:cNvPr id="56" name="Text 54"/>
-          <p:cNvSpPr/>
-          <p:nvPr/>
-        </p:nvSpPr>
-        <p:spPr>
-          <a:xfrm>
-            <a:off x="365760" y="6199632"/>
-            <a:ext cx="11460175" cy="228600"/>
-          </a:xfrm>
-          <a:prstGeom prst="rect">
-            <a:avLst/>
-          </a:prstGeom>
-          <a:noFill/>
-          <a:ln/>
-        </p:spPr>
-        <p:txBody>
-          <a:bodyPr wrap="square" lIns="0" tIns="0" rIns="0" bIns="0" rtlCol="0" anchor="ctr">
-            <a:normAutofit/>
-          </a:bodyPr>
-          <a:lstStyle/>
-          <a:p>
-            <a:pPr rtl="1" algn="r" indent="0" marL="0">
-              <a:buNone/>
-            </a:pPr>
-            <a:r>
-              <a:rPr lang="ar-SA" altLang="en-US" sz="750" dirty="0">
-                <a:solidFill>
-                  <a:srgbClr val="66707A"/>
-                </a:solidFill>
-                <a:latin typeface="Arial" pitchFamily="34" charset="0"/>
-                <a:ea typeface="Arial" pitchFamily="34" charset="-122"/>
-                <a:cs typeface="Arial" pitchFamily="34" charset="-120"/>
-              </a:rPr>
-              <a:t>المصدر: برنامج شركة الخليج للتطوير للمقاولات – المراجعة 01 (12 أكتوبر 2026)، مُحال من مدير الإنشاءات في SAR</a:t>
-            </a:r>
-            <a:endParaRPr lang="ar-SA" sz="750" dirty="0"/>
-          </a:p>
-        </p:txBody>
-      </p:sp>
-      <p:sp>
-        <p:nvSpPr>
-          <p:cNvPr id="25" name="Slide Number Placeholder 0"/>
-          <p:cNvSpPr>
-            <a:spLocks noGrp="1"/>
-          </p:cNvSpPr>
-          <p:nvPr>
-            <p:ph type="sldNum" sz="quarter" idx="4294967295"/>
-          </p:nvPr>
-        </p:nvSpPr>
-        <p:spPr>
-          <a:xfrm>
-            <a:off x="320040" y="6519672"/>
-            <a:ext cx="548640" cy="310896"/>
-          </a:xfrm>
-          <a:prstGeom prst="rect">
-            <a:avLst/>
-          </a:prstGeom>
-          <a:extLst>
-            <a:ext uri="{C572A759-6A51-4108-AA02-DFA0A04FC94B}">
-              <ma14:wrappingTextBoxFlag xmlns:ma14="http://schemas.microsoft.com/office/mac/drawingml/2011/main" val="0"/>
-            </a:ext>
-          </a:extLst>
-        </p:spPr>
-        <p:txBody>
-          <a:bodyPr/>
-          <a:lstStyle>
-            <a:lvl1pPr>
-              <a:defRPr sz="1000">
-                <a:solidFill>
-                  <a:srgbClr val="FFFFFF"/>
-                </a:solidFill>
-                <a:latin typeface="Arial"/>
-                <a:ea typeface="Arial"/>
-                <a:cs typeface="Arial"/>
-              </a:defRPr>
-            </a:lvl1pPr>
-          </a:lstStyle>
-          <a:p>
-            <a:pPr algn="ctr"/>
-            <a:fld id="{F7021451-1387-4CA6-816F-3879F97B5CBC}" type="slidenum">
-              <a:rPr b="0" lang="en-US"/>
-              <a:t>3</a:t>
             </a:fld>
             <a:endParaRPr lang="en-US"/>
           </a:p>

</xml_diff>

<commit_message>
Fix PowerPoint export (invalid ellipse adj dropped rows in PowerPoint) and add ruler to remaining-works Gantt
Co-Authored-By: Claude Sonnet 5.5 <noreply@anthropic.com>
Claude-Session: https://claude.ai/code/session_015CooLRRU7X55XCWBXAPEMd
</commit_message>
<xml_diff>
--- a/ufwl-timeline/UFWL_Presentation_AR.pptx
+++ b/ufwl-timeline/UFWL_Presentation_AR.pptx
@@ -14348,9 +14348,7 @@
             <a:ext cx="237744" cy="237744"/>
           </a:xfrm>
           <a:prstGeom prst="ellipse">
-            <a:avLst>
-              <a:gd name="adj" fmla="val 32692"/>
-            </a:avLst>
+            <a:avLst/>
           </a:prstGeom>
           <a:solidFill>
             <a:srgbClr val="C8503F"/>
@@ -16545,9 +16543,7 @@
             <a:ext cx="237744" cy="237744"/>
           </a:xfrm>
           <a:prstGeom prst="ellipse">
-            <a:avLst>
-              <a:gd name="adj" fmla="val 32692"/>
-            </a:avLst>
+            <a:avLst/>
           </a:prstGeom>
           <a:solidFill>
             <a:srgbClr val="00778B"/>
@@ -16877,9 +16873,7 @@
             <a:ext cx="237744" cy="237744"/>
           </a:xfrm>
           <a:prstGeom prst="ellipse">
-            <a:avLst>
-              <a:gd name="adj" fmla="val 32692"/>
-            </a:avLst>
+            <a:avLst/>
           </a:prstGeom>
           <a:solidFill>
             <a:srgbClr val="00778B"/>
@@ -17250,9 +17244,7 @@
             <a:ext cx="237744" cy="237744"/>
           </a:xfrm>
           <a:prstGeom prst="ellipse">
-            <a:avLst>
-              <a:gd name="adj" fmla="val 32692"/>
-            </a:avLst>
+            <a:avLst/>
           </a:prstGeom>
           <a:solidFill>
             <a:srgbClr val="00778B"/>
@@ -17623,9 +17615,7 @@
             <a:ext cx="237744" cy="237744"/>
           </a:xfrm>
           <a:prstGeom prst="ellipse">
-            <a:avLst>
-              <a:gd name="adj" fmla="val 32692"/>
-            </a:avLst>
+            <a:avLst/>
           </a:prstGeom>
           <a:solidFill>
             <a:srgbClr val="00778B"/>
@@ -17996,9 +17986,7 @@
             <a:ext cx="237744" cy="237744"/>
           </a:xfrm>
           <a:prstGeom prst="ellipse">
-            <a:avLst>
-              <a:gd name="adj" fmla="val 32692"/>
-            </a:avLst>
+            <a:avLst/>
           </a:prstGeom>
           <a:solidFill>
             <a:srgbClr val="2E9E6B"/>
@@ -18369,9 +18357,7 @@
             <a:ext cx="237744" cy="237744"/>
           </a:xfrm>
           <a:prstGeom prst="ellipse">
-            <a:avLst>
-              <a:gd name="adj" fmla="val 32692"/>
-            </a:avLst>
+            <a:avLst/>
           </a:prstGeom>
           <a:solidFill>
             <a:srgbClr val="D68A00"/>

</xml_diff>